<commit_message>
Update PPT with links and add README.md
</commit_message>
<xml_diff>
--- a/presentation.pptx
+++ b/presentation.pptx
@@ -3165,7 +3165,19 @@
               </a:defRPr>
             </a:pPr>
             <a:r>
+              <a:t>ALOK SALI (46854973)</a:t>
+            </a:r>
+            <a:br/>
+            <a:r>
               <a:t>Final Individual Project • Data Visualization • Summer 2026</a:t>
+            </a:r>
+            <a:br/>
+            <a:r>
+              <a:t>Live App: https://dataviz-final-project-alok-sali-46854973.streamlit.app/</a:t>
+            </a:r>
+            <a:br/>
+            <a:r>
+              <a:t>GitHub: https://github.com/Alok-LOKI/dataviz-FINAL-PROJECT-ALOK-SALI-46854973</a:t>
             </a:r>
           </a:p>
         </p:txBody>

</xml_diff>